<commit_message>
fix: gop bo rule den/quat qua gateway, gioi han topic config
- Flow: tat 2 rule trung va MQTT Out truc tiep tren tab Nguoi 3; 9 nut
  test lenh di qua gateway (khoa AUTO/MANUAL, ACK, lich su lenh). Rule
  tuan 7 dung gia tri nhom thong nhat: den tat 21:00, quat 60 s.
- Firmware: topic config chi nhan so trong pham vi an toan, giu khoang
  hysteresis, khong cho ha nguong khoa nuoc duoi 1200; goi sai bi
  REJECTED va giu nguong cu.
- Test, README, bang chung e2e (chay lai voi tab Nguoi 3) va slide
  bao cao tuan 6-7 cap nhat theo.

Co-Authored-By: Claude Opus 5.5 (1M context) <noreply@anthropic.com>
</commit_message>
<xml_diff>
--- a/docs/bao-cao-tuan-6-7.pptx
+++ b/docs/bao-cao-tuan-6-7.pptx
@@ -120,19 +120,19 @@
   <p:extLst>
     <p:ext uri="{521415D9-36F7-43E2-AB2F-B90AF26B5E84}">
       <p14:sectionLst xmlns:p14="http://schemas.microsoft.com/office/powerpoint/2010/main">
-        <p14:section name="Mở đầu" id="{0b604361-b1fb-7be3-398e-ce8a054232ef}">
+        <p14:section name="Mở đầu" id="{a1ce52bd-e977-4353-5431-b70c25cce5a4}">
           <p14:sldIdLst>
             <p14:sldId id="256"/>
             <p14:sldId id="257"/>
           </p14:sldIdLst>
         </p14:section>
-        <p14:section name="Mục tiêu" id="{307b4238-5973-cc21-c1ea-6437a0e421f8}">
+        <p14:section name="Mục tiêu" id="{8bb4f026-1a9f-ed86-0cd7-7a6628995330}">
           <p14:sldIdLst>
             <p14:sldId id="258"/>
             <p14:sldId id="259"/>
           </p14:sldIdLst>
         </p14:section>
-        <p14:section name="Tuần 6" id="{8bc3c63a-8357-ec8d-abbe-a8d889db7d31}">
+        <p14:section name="Tuần 6" id="{cc13c554-05ea-421e-4360-487613643d74}">
           <p14:sldIdLst>
             <p14:sldId id="260"/>
             <p14:sldId id="261"/>
@@ -140,14 +140,14 @@
             <p14:sldId id="263"/>
           </p14:sldIdLst>
         </p14:section>
-        <p14:section name="Tuần 7" id="{4ae15dff-9ff8-2bcb-1258-631db7e0f3a0}">
+        <p14:section name="Tuần 7" id="{42a872b9-2cf8-8cb9-9fca-35edd8c7f4d2}">
           <p14:sldIdLst>
             <p14:sldId id="264"/>
             <p14:sldId id="265"/>
             <p14:sldId id="266"/>
           </p14:sldIdLst>
         </p14:section>
-        <p14:section name="Kết quả" id="{573450ce-5184-5df9-0e8a-4c8fa69644b0}">
+        <p14:section name="Kết quả" id="{4cc332a5-ad8a-da03-f28c-a54aaba53807}">
           <p14:sldIdLst>
             <p14:sldId id="267"/>
             <p14:sldId id="268"/>
@@ -737,7 +737,7 @@
             <a:r>
               <a:rPr lang="en-US" dirty="0"/>
               <a:t>Đây là tình huống bất thường đã chạy thật trong lượt end-to-end: Node-RED và dashboard thật, thiết bị là bộ mô phỏng nói đúng giao thức MQTT của firmware. Các mốc thời gian lấy từ log.
-Đang phun AUTO thì giả lập DHT lỗi; sau 3 lần đọc lỗi, khoảng 7,7 giây, hệ thống vào SENSOR_FAULT và tắt phun. Tiếp theo nước thấp: WATER_LOCKOUT được ưu tiên hơn lỗi cảm biến. Đổ nước lại nhưng DHT vẫn lỗi nên quay về SENSOR_FAULT. DHT hồi phục thì qua COOLDOWN rồi mới được phun. Sau đó ngắt kết nối 20 giây: broker phát Last Will, dashboard báo OFFLINE, thiết bị xoá lệnh tay. Khi online lại, rule đèn tự phát hiện lệnh giữ đã mất và gửi lại.
+Đang phun AUTO thì giả lập DHT lỗi; sau 3 lần đọc lỗi, khoảng 7,6 giây, hệ thống vào SENSOR_FAULT và tắt phun. Tiếp theo nước thấp: WATER_LOCKOUT được ưu tiên hơn lỗi cảm biến. Đổ nước lại nhưng DHT vẫn lỗi nên quay về SENSOR_FAULT. DHT hồi phục thì qua COOLDOWN rồi mới được phun. Sau đó ngắt kết nối 20 giây: broker phát Last Will, dashboard báo OFFLINE, thiết bị xoá lệnh tay. Khi online lại, rule đèn tự phát hiện lệnh giữ đã mất và gửi lại.
 Ngoài ra có lệnh không ACK, lệnh bị firmware từ chối, và trong toàn bộ lượt chạy không có vi phạm an toàn nào. Lưu ý trung thực: đây là bộ mô phỏng giao thức; logic firmware tương ứng có scenario Wokwi riêng.</a:t>
             </a:r>
             <a:endParaRPr lang="en-US" dirty="0"/>
@@ -826,7 +826,7 @@
           <a:p>
             <a:r>
               <a:rPr lang="en-US" dirty="0"/>
-              <a:t>Kết quả có bằng chứng: bộ test Node-RED chạy PASS; lượt chạy end-to-end bằng Chrome trên Node-RED thật đạt, có 13 ảnh và 189 sự kiện trong event log; firmware build được cả 3 cấu hình. Người 3 lập ma trận kiểm thử 12 ca có phân định mô phỏng và board thật.
+              <a:t>Kết quả có bằng chứng: bộ test Node-RED chạy PASS; lượt chạy end-to-end bằng Chrome trên Node-RED thật (đã có cả tab Người 3) đạt, có 13 ảnh và 281 sự kiện, toàn bộ 46 lệnh đều đi qua gateway; cảnh báo của Người 3 cũng chạy trong lượt này; firmware build được cả 3 cấu hình. Người 3 lập ma trận kiểm thử 12 ca có phân định mô phỏng và board thật.
 Nói rõ phần chưa xong: hai scenario Wokwi mới đã viết nhưng chưa chạy trên Wokwi CI; Telegram cần token thật để gửi và quay video; chưa chạy trên board ESP32 thật.</a:t>
             </a:r>
             <a:endParaRPr lang="en-US" dirty="0"/>
@@ -915,7 +915,8 @@
           <a:p>
             <a:r>
               <a:rPr lang="en-US" dirty="0"/>
-              <a:t>Những việc còn lại trước buổi demo. Thứ nhất, hai bộ rule đèn và quạt đang trùng nhau giữa tab Tuần 7 và tab Người 3, khác giờ tắt và thời lượng quạt; tab Người 3 gửi lệnh không qua gateway nên không dừng khi dashboard ở MANUAL — nhóm cần thống nhất giữ một bộ. Thứ hai, topic config đổi ngưỡng từ xa chưa kiểm tra phạm vi; trên broker công khai cần giới hạn hoặc tắt để không vô hiệu hoá khoá nước. Sau đó là chạy hai scenario Wokwi mới, cấu hình Telegram thật và quay video, và cuối cùng đưa các khoá an toàn lên firmware board thật.</a:t>
+              <a:t>Sau khi gộp nhánh của Người 2 và Người 3, nhóm phát hiện và đã xử lý hai rủi ro. Thứ nhất, hai bộ rule đèn và quạt chạy song song và giành nhau điều khiển; nay chỉ còn bộ rule trên tab Tuần 7, đi qua gateway, dùng giá trị nhóm đã thống nhất: đèn tắt 21:00, quạt chạy 60 giây sau mỗi chu kỳ phun. Các nút test lệnh của tab Người 3 cũng đi qua gateway nên bị khoá khi dashboard ở AUTO. Thứ hai, topic config đổi ngưỡng từ xa trước đây nhận mọi giá trị; nay firmware chỉ nhận số trong phạm vi an toàn và không cho hạ ngưỡng khoá nước dưới 1200.
+Việc còn lại trước buổi demo: chạy hai scenario Wokwi mới, cấu hình Telegram thật và quay video, và đưa các khoá an toàn lên firmware board thật.</a:t>
             </a:r>
             <a:endParaRPr lang="en-US" dirty="0"/>
           </a:p>
@@ -1447,7 +1448,7 @@
             <a:r>
               <a:rPr lang="en-US" dirty="0"/>
               <a:t>Lưu ý điều khiển của tuần 6: payload phải khớp firmware hiện tại. Mọi nút trên dashboard đều đi qua một gateway duy nhất, gửi tới đúng topic cmd/mist, cmd/fan hoặc cmd/light, với request_id, mode MANUAL kèm state ON/OFF và ttl_s, hoặc mode AUTO. QoS 1 và không retain.
-Gateway theo dõi ACK theo request_id: APPLIED là firmware đã làm; REJECTED kèm lý do như WATER_LOCKOUT; quá 6 giây không có ACK thì báo NO_ACK; còn BLOCKED là lệnh bị chặn ngay ở Node-RED vì sai quyền, sai chế độ hoặc thiết bị offline. Bảng lịch sử bên phải là dữ liệu thật của lượt chạy mô phỏng: có cả APPLIED, REJECTED do cạn nước và NO_ACK.</a:t>
+Gateway theo dõi ACK theo request_id: APPLIED là firmware đã làm; REJECTED kèm lý do như WATER_LOCKOUT; quá 6 giây không có ACK thì báo NO_ACK; còn BLOCKED là lệnh bị chặn ngay ở Node-RED vì sai quyền, sai chế độ hoặc thiết bị offline. Bảng lịch sử bên phải là dữ liệu thật của lượt chạy mô phỏng: có cả APPLIED, REJECTED do cạn nước và NO_ACK. Các nút test lệnh trong editor của tab Người 3 cũng đi qua đúng gateway này.</a:t>
             </a:r>
             <a:endParaRPr lang="en-US" dirty="0"/>
           </a:p>
@@ -1715,9 +1716,9 @@
             <a:r>
               <a:rPr lang="en-US" dirty="0"/>
               <a:t>Tuần 7, Người 1 làm 2 automation rule; cả hai tự gửi lệnh khi dashboard ở AUTO, không phải bấm nút.
-Rule 1 — đèn theo khung giờ: chỉ chiếu sáng trong 06:00 đến 20:00 khi trời tối, có giờ tắt 20:00 và tổng thời lượng bật tối đa 240 phút mỗi ngày. Ngoài khung giờ rule giữ đèn tắt, vì logic LDR của firmware sẽ bật đèn suốt đêm nếu không có rule.
-Rule 2 — quạt hỗ trợ: sau mỗi chu kỳ phun, quạt bật 180 giây rồi firmware tự trả về AUTO khi hết TTL, nên không chạy cả đêm.
-Thử bằng lịch rút ngắn 60 lần: bảng sự kiện bên trái là event log thật — đèn bật lúc 06:00, chạm giới hạn lúc 07:00 và tắt; quạt hỗ trợ hai lần sau hai chu kỳ phun. Bàn giao gồm flow export và event log.</a:t>
+Rule 1 — đèn theo khung giờ: chỉ chiếu sáng trong 06:00 đến 21:00 khi trời tối, có giờ tắt 21:00 và tổng thời lượng bật tối đa 240 phút mỗi ngày. Ngoài khung giờ rule giữ đèn tắt, vì logic LDR của firmware sẽ bật đèn suốt đêm nếu không có rule.
+Rule 2 — quạt hỗ trợ: sau mỗi chu kỳ phun, quạt bật 60 giây rồi firmware tự trả về AUTO khi hết TTL, nên không chạy cả đêm.
+Thử bằng lịch rút ngắn 60 lần: bảng sự kiện bên trái là event log thật — đèn bật lúc 06:00, chạm giới hạn lúc 07:00 và tắt; quạt hỗ trợ hai lần sau hai chu kỳ phun. Giờ tắt 21:00 và quạt 60 giây là giá trị nhóm đã thống nhất trong ma trận kiểm thử; hai rule trùng trên tab Người 3 đã được gộp vào đây nên chỉ còn một bộ automation. Bàn giao gồm flow export và event log.</a:t>
             </a:r>
             <a:endParaRPr lang="en-US" dirty="0"/>
           </a:p>
@@ -4002,7 +4003,7 @@
                 <a:ea typeface="Arial" pitchFamily="34" charset="-122"/>
                 <a:cs typeface="Arial" pitchFamily="34" charset="-120"/>
               </a:rPr>
-              <a:t>+7,7 s</a:t>
+              <a:t>+7,6 s</a:t>
             </a:r>
             <a:endParaRPr lang="en-US" sz="1200" dirty="0"/>
           </a:p>
@@ -4144,7 +4145,7 @@
                 <a:ea typeface="Arial" pitchFamily="34" charset="-122"/>
                 <a:cs typeface="Arial" pitchFamily="34" charset="-120"/>
               </a:rPr>
-              <a:t>+10,1 s</a:t>
+              <a:t>+10,0 s</a:t>
             </a:r>
             <a:endParaRPr lang="en-US" sz="1200" dirty="0"/>
           </a:p>
@@ -4286,7 +4287,7 @@
                 <a:ea typeface="Arial" pitchFamily="34" charset="-122"/>
                 <a:cs typeface="Arial" pitchFamily="34" charset="-120"/>
               </a:rPr>
-              <a:t>+15,3 s</a:t>
+              <a:t>+15,1 s</a:t>
             </a:r>
             <a:endParaRPr lang="en-US" sz="1200" dirty="0"/>
           </a:p>
@@ -4428,7 +4429,7 @@
                 <a:ea typeface="Arial" pitchFamily="34" charset="-122"/>
                 <a:cs typeface="Arial" pitchFamily="34" charset="-120"/>
               </a:rPr>
-              <a:t>+17,7 s</a:t>
+              <a:t>+17,4 s</a:t>
             </a:r>
             <a:endParaRPr lang="en-US" sz="1200" dirty="0"/>
           </a:p>
@@ -4570,7 +4571,7 @@
                 <a:ea typeface="Arial" pitchFamily="34" charset="-122"/>
                 <a:cs typeface="Arial" pitchFamily="34" charset="-120"/>
               </a:rPr>
-              <a:t>+17,9 s</a:t>
+              <a:t>+17,7 s</a:t>
             </a:r>
             <a:endParaRPr lang="en-US" sz="1200" dirty="0"/>
           </a:p>
@@ -4712,7 +4713,7 @@
                 <a:ea typeface="Arial" pitchFamily="34" charset="-122"/>
                 <a:cs typeface="Arial" pitchFamily="34" charset="-120"/>
               </a:rPr>
-              <a:t>+40,2 s</a:t>
+              <a:t>+40,1 s</a:t>
             </a:r>
             <a:endParaRPr lang="en-US" sz="1200" dirty="0"/>
           </a:p>
@@ -5000,7 +5001,7 @@
                 <a:ea typeface="Arial" pitchFamily="34" charset="-122"/>
                 <a:cs typeface="Arial" pitchFamily="34" charset="-120"/>
               </a:rPr>
-              <a:t>Mist ON khi nước vừa cạn → REJECTED (WATER_LOCKOUT) sau 0,5 s</a:t>
+              <a:t>Mist ON khi nước vừa cạn → REJECTED (WATER_LOCKOUT), độ trễ ACK 5 ms</a:t>
             </a:r>
             <a:endParaRPr lang="en-US" sz="1300" dirty="0"/>
           </a:p>
@@ -5509,7 +5510,7 @@
                 <a:ea typeface="Arial" pitchFamily="34" charset="-122"/>
                 <a:cs typeface="Arial" pitchFamily="34" charset="-120"/>
               </a:rPr>
-              <a:t>Lượt chạy end-to-end bằng Chrome: 13 ảnh, 189 sự kiện trong event log</a:t>
+              <a:t>Lượt chạy end-to-end bằng Chrome: 13 ảnh, 281 sự kiện, mọi lệnh đi qua gateway</a:t>
             </a:r>
             <a:endParaRPr lang="en-US" sz="1200" dirty="0"/>
           </a:p>
@@ -5767,7 +5768,7 @@
                 <a:ea typeface="Arial" pitchFamily="34" charset="-122"/>
                 <a:cs typeface="Arial" pitchFamily="34" charset="-120"/>
               </a:rPr>
-              <a:t>Thiết bị mô phỏng sim-device.cjs để thử dashboard khi không chạy Wokwi; có sẵn kịch bản fault-demo</a:t>
+              <a:t>Cảnh báo của Người 3 chạy trong cùng lượt: nước thấp, lỗi DHT, offline, lệnh bị từ chối</a:t>
             </a:r>
             <a:endParaRPr lang="en-US" sz="1400" dirty="0"/>
           </a:p>
@@ -6070,7 +6071,7 @@
                 <a:ea typeface="Times New Roman" pitchFamily="34" charset="-122"/>
                 <a:cs typeface="Times New Roman" pitchFamily="34" charset="-120"/>
               </a:rPr>
-              <a:t>Tồn tại và việc tiếp theo</a:t>
+              <a:t>Đã xử lý và việc tiếp theo</a:t>
             </a:r>
             <a:endParaRPr lang="en-US" sz="3400" dirty="0"/>
           </a:p>
@@ -6111,7 +6112,7 @@
                 <a:ea typeface="Times New Roman" pitchFamily="34" charset="-122"/>
                 <a:cs typeface="Times New Roman" pitchFamily="34" charset="-120"/>
               </a:rPr>
-              <a:t>Các điểm cần xử lý trước buổi demo</a:t>
+              <a:t>Hai rủi ro phát hiện sau khi gộp nhánh đã được sửa; còn 3 việc trước buổi demo</a:t>
             </a:r>
             <a:endParaRPr lang="en-US" sz="1600" dirty="0"/>
           </a:p>
@@ -6119,162 +6120,24 @@
       </p:sp>
       <p:sp>
         <p:nvSpPr>
-          <p:cNvPr id="4" name="issue badge 1"/>
+          <p:cNvPr id="4" name="fixed panel"/>
           <p:cNvSpPr/>
           <p:nvPr/>
         </p:nvSpPr>
         <p:spPr>
           <a:xfrm>
-            <a:off x="548640" y="1847088"/>
-            <a:ext cx="457200" cy="457200"/>
-          </a:xfrm>
-          <a:prstGeom prst="ellipse">
-            <a:avLst/>
+            <a:off x="548640" y="1691640"/>
+            <a:ext cx="5394960" cy="4480560"/>
+          </a:xfrm>
+          <a:prstGeom prst="roundRect">
+            <a:avLst>
+              <a:gd name="adj" fmla="val 1633"/>
+            </a:avLst>
           </a:prstGeom>
           <a:solidFill>
-            <a:schemeClr val="accent4"/>
+            <a:schemeClr val="bg2"/>
           </a:solidFill>
           <a:ln w="12700">
-            <a:solidFill>
-              <a:schemeClr val="accent4"/>
-            </a:solidFill>
-            <a:prstDash val="solid"/>
-          </a:ln>
-        </p:spPr>
-      </p:sp>
-      <p:sp>
-        <p:nvSpPr>
-          <p:cNvPr id="5" name="issue number 1"/>
-          <p:cNvSpPr txBox="1"/>
-          <p:nvPr/>
-        </p:nvSpPr>
-        <p:spPr>
-          <a:xfrm>
-            <a:off x="548640" y="1847088"/>
-            <a:ext cx="457200" cy="457200"/>
-          </a:xfrm>
-          <a:prstGeom prst="rect">
-            <a:avLst/>
-          </a:prstGeom>
-          <a:noFill/>
-          <a:ln/>
-        </p:spPr>
-        <p:txBody>
-          <a:bodyPr wrap="square" lIns="0" tIns="0" rIns="0" bIns="0" rtlCol="0" anchor="ctr"/>
-          <a:lstStyle/>
-          <a:p>
-            <a:pPr algn="ctr" indent="0" marL="0">
-              <a:buNone/>
-            </a:pPr>
-            <a:r>
-              <a:rPr lang="en-US" sz="1600" b="1" dirty="0">
-                <a:solidFill>
-                  <a:schemeClr val="bg1"/>
-                </a:solidFill>
-                <a:latin typeface="Times New Roman" pitchFamily="34" charset="0"/>
-                <a:ea typeface="Times New Roman" pitchFamily="34" charset="-122"/>
-                <a:cs typeface="Times New Roman" pitchFamily="34" charset="-120"/>
-              </a:rPr>
-              <a:t>1</a:t>
-            </a:r>
-            <a:endParaRPr lang="en-US" sz="1600" dirty="0"/>
-          </a:p>
-        </p:txBody>
-      </p:sp>
-      <p:sp>
-        <p:nvSpPr>
-          <p:cNvPr id="6" name="issue title 1"/>
-          <p:cNvSpPr txBox="1"/>
-          <p:nvPr/>
-        </p:nvSpPr>
-        <p:spPr>
-          <a:xfrm>
-            <a:off x="1188720" y="1691640"/>
-            <a:ext cx="3017520" cy="768096"/>
-          </a:xfrm>
-          <a:prstGeom prst="rect">
-            <a:avLst/>
-          </a:prstGeom>
-          <a:noFill/>
-          <a:ln/>
-        </p:spPr>
-        <p:txBody>
-          <a:bodyPr wrap="square" lIns="0" tIns="0" rIns="0" bIns="0" rtlCol="0" anchor="ctr"/>
-          <a:lstStyle/>
-          <a:p>
-            <a:pPr indent="0" marL="0">
-              <a:buNone/>
-            </a:pPr>
-            <a:r>
-              <a:rPr lang="en-US" sz="1700" b="1" dirty="0">
-                <a:solidFill>
-                  <a:schemeClr val="tx2"/>
-                </a:solidFill>
-                <a:latin typeface="Times New Roman" pitchFamily="34" charset="0"/>
-                <a:ea typeface="Times New Roman" pitchFamily="34" charset="-122"/>
-                <a:cs typeface="Times New Roman" pitchFamily="34" charset="-120"/>
-              </a:rPr>
-              <a:t>Gộp 2 bộ rule đèn/quạt</a:t>
-            </a:r>
-            <a:endParaRPr lang="en-US" sz="1700" dirty="0"/>
-          </a:p>
-        </p:txBody>
-      </p:sp>
-      <p:sp>
-        <p:nvSpPr>
-          <p:cNvPr id="7" name="issue desc 1"/>
-          <p:cNvSpPr txBox="1"/>
-          <p:nvPr/>
-        </p:nvSpPr>
-        <p:spPr>
-          <a:xfrm>
-            <a:off x="4297680" y="1691640"/>
-            <a:ext cx="7315200" cy="768096"/>
-          </a:xfrm>
-          <a:prstGeom prst="rect">
-            <a:avLst/>
-          </a:prstGeom>
-          <a:noFill/>
-          <a:ln/>
-        </p:spPr>
-        <p:txBody>
-          <a:bodyPr wrap="square" lIns="0" tIns="0" rIns="0" bIns="0" rtlCol="0" anchor="ctr"/>
-          <a:lstStyle/>
-          <a:p>
-            <a:pPr indent="0" marL="0">
-              <a:buNone/>
-            </a:pPr>
-            <a:r>
-              <a:rPr lang="en-US" sz="1300" dirty="0">
-                <a:solidFill>
-                  <a:schemeClr val="tx1"/>
-                </a:solidFill>
-                <a:latin typeface="Arial" pitchFamily="34" charset="0"/>
-                <a:ea typeface="Arial" pitchFamily="34" charset="-122"/>
-                <a:cs typeface="Arial" pitchFamily="34" charset="-120"/>
-              </a:rPr>
-              <a:t>Tab Tuần 7 và tab Người 3 cùng điều khiển đèn và quạt (giờ tắt 20:00 vs 21:00; quạt 180 s vs 60 s). Tab Người 3 gửi lệnh không qua gateway nên không dừng khi dashboard ở MANUAL.</a:t>
-            </a:r>
-            <a:endParaRPr lang="en-US" sz="1300" dirty="0"/>
-          </a:p>
-        </p:txBody>
-      </p:sp>
-      <p:sp>
-        <p:nvSpPr>
-          <p:cNvPr id="8" name="issue divider 1"/>
-          <p:cNvSpPr/>
-          <p:nvPr/>
-        </p:nvSpPr>
-        <p:spPr>
-          <a:xfrm>
-            <a:off x="1188720" y="2514600"/>
-            <a:ext cx="10451592" cy="0"/>
-          </a:xfrm>
-          <a:prstGeom prst="line">
-            <a:avLst/>
-          </a:prstGeom>
-          <a:noFill/>
-          <a:ln w="9525">
             <a:solidFill>
               <a:schemeClr val="accent5"/>
             </a:solidFill>
@@ -6284,24 +6147,269 @@
       </p:sp>
       <p:sp>
         <p:nvSpPr>
-          <p:cNvPr id="9" name="issue badge 2"/>
+          <p:cNvPr id="5" name="fixed heading"/>
+          <p:cNvSpPr txBox="1"/>
+          <p:nvPr/>
+        </p:nvSpPr>
+        <p:spPr>
+          <a:xfrm>
+            <a:off x="868680" y="1874520"/>
+            <a:ext cx="4846320" cy="329184"/>
+          </a:xfrm>
+          <a:prstGeom prst="rect">
+            <a:avLst/>
+          </a:prstGeom>
+          <a:noFill/>
+          <a:ln/>
+        </p:spPr>
+        <p:txBody>
+          <a:bodyPr wrap="square" lIns="0" tIns="0" rIns="0" bIns="0" rtlCol="0" anchor="ctr"/>
+          <a:lstStyle/>
+          <a:p>
+            <a:pPr indent="0" marL="0">
+              <a:buNone/>
+            </a:pPr>
+            <a:r>
+              <a:rPr lang="en-US" sz="1500" b="1" spc="100" kern="0" dirty="0">
+                <a:solidFill>
+                  <a:schemeClr val="tx2"/>
+                </a:solidFill>
+                <a:latin typeface="Times New Roman" pitchFamily="34" charset="0"/>
+                <a:ea typeface="Times New Roman" pitchFamily="34" charset="-122"/>
+                <a:cs typeface="Times New Roman" pitchFamily="34" charset="-120"/>
+              </a:rPr>
+              <a:t>ĐÃ XỬ LÝ SAU KHI GỘP NHÁNH</a:t>
+            </a:r>
+            <a:endParaRPr lang="en-US" sz="1500" dirty="0"/>
+          </a:p>
+        </p:txBody>
+      </p:sp>
+      <p:pic>
+        <p:nvPicPr>
+          <p:cNvPr id="6" name="fixed icon 1" descr="Đã xử lý">    </p:cNvPr>
+          <p:cNvPicPr>
+            <a:picLocks noChangeAspect="1"/>
+          </p:cNvPicPr>
+          <p:nvPr/>
+        </p:nvPicPr>
+        <p:blipFill>
+          <a:blip r:embed="rId1"/>
+          <a:stretch>
+            <a:fillRect/>
+          </a:stretch>
+        </p:blipFill>
+        <p:spPr>
+          <a:xfrm>
+            <a:off x="868680" y="2404872"/>
+            <a:ext cx="329184" cy="329184"/>
+          </a:xfrm>
+          <a:prstGeom prst="rect">
+            <a:avLst/>
+          </a:prstGeom>
+        </p:spPr>
+      </p:pic>
+      <p:sp>
+        <p:nvSpPr>
+          <p:cNvPr id="7" name="fixed title 1"/>
+          <p:cNvSpPr txBox="1"/>
+          <p:nvPr/>
+        </p:nvSpPr>
+        <p:spPr>
+          <a:xfrm>
+            <a:off x="1325880" y="2377440"/>
+            <a:ext cx="4389120" cy="384048"/>
+          </a:xfrm>
+          <a:prstGeom prst="rect">
+            <a:avLst/>
+          </a:prstGeom>
+          <a:noFill/>
+          <a:ln/>
+        </p:spPr>
+        <p:txBody>
+          <a:bodyPr wrap="square" lIns="0" tIns="0" rIns="0" bIns="0" rtlCol="0" anchor="ctr"/>
+          <a:lstStyle/>
+          <a:p>
+            <a:pPr indent="0" marL="0">
+              <a:buNone/>
+            </a:pPr>
+            <a:r>
+              <a:rPr lang="en-US" sz="1700" b="1" dirty="0">
+                <a:solidFill>
+                  <a:schemeClr val="tx2"/>
+                </a:solidFill>
+                <a:latin typeface="Times New Roman" pitchFamily="34" charset="0"/>
+                <a:ea typeface="Times New Roman" pitchFamily="34" charset="-122"/>
+                <a:cs typeface="Times New Roman" pitchFamily="34" charset="-120"/>
+              </a:rPr>
+              <a:t>Một bộ rule đèn/quạt</a:t>
+            </a:r>
+            <a:endParaRPr lang="en-US" sz="1700" dirty="0"/>
+          </a:p>
+        </p:txBody>
+      </p:sp>
+      <p:sp>
+        <p:nvSpPr>
+          <p:cNvPr id="8" name="fixed desc 1"/>
+          <p:cNvSpPr txBox="1"/>
+          <p:nvPr/>
+        </p:nvSpPr>
+        <p:spPr>
+          <a:xfrm>
+            <a:off x="1325880" y="2788920"/>
+            <a:ext cx="4389120" cy="1280160"/>
+          </a:xfrm>
+          <a:prstGeom prst="rect">
+            <a:avLst/>
+          </a:prstGeom>
+          <a:noFill/>
+          <a:ln/>
+        </p:spPr>
+        <p:txBody>
+          <a:bodyPr wrap="square" lIns="0" tIns="0" rIns="0" bIns="0" rtlCol="0" anchor="t"/>
+          <a:lstStyle/>
+          <a:p>
+            <a:pPr indent="0" marL="0">
+              <a:buNone/>
+            </a:pPr>
+            <a:r>
+              <a:rPr lang="en-US" sz="1300" dirty="0">
+                <a:solidFill>
+                  <a:schemeClr val="tx1"/>
+                </a:solidFill>
+                <a:latin typeface="Arial" pitchFamily="34" charset="0"/>
+                <a:ea typeface="Arial" pitchFamily="34" charset="-122"/>
+                <a:cs typeface="Arial" pitchFamily="34" charset="-120"/>
+              </a:rPr>
+              <a:t>Rule trùng trên tab Người 3 đã tắt; tab Tuần 7 dùng giá trị nhóm thống nhất (đèn tắt 21:00, quạt 60 s). Nút test lệnh cũng đi qua gateway nên dừng khi dashboard ở MANUAL.</a:t>
+            </a:r>
+            <a:endParaRPr lang="en-US" sz="1300" dirty="0"/>
+          </a:p>
+        </p:txBody>
+      </p:sp>
+      <p:pic>
+        <p:nvPicPr>
+          <p:cNvPr id="9" name="fixed icon 2" descr="Đã xử lý">    </p:cNvPr>
+          <p:cNvPicPr>
+            <a:picLocks noChangeAspect="1"/>
+          </p:cNvPicPr>
+          <p:nvPr/>
+        </p:nvPicPr>
+        <p:blipFill>
+          <a:blip r:embed="rId2"/>
+          <a:stretch>
+            <a:fillRect/>
+          </a:stretch>
+        </p:blipFill>
+        <p:spPr>
+          <a:xfrm>
+            <a:off x="868680" y="4233672"/>
+            <a:ext cx="329184" cy="329184"/>
+          </a:xfrm>
+          <a:prstGeom prst="rect">
+            <a:avLst/>
+          </a:prstGeom>
+        </p:spPr>
+      </p:pic>
+      <p:sp>
+        <p:nvSpPr>
+          <p:cNvPr id="10" name="fixed title 2"/>
+          <p:cNvSpPr txBox="1"/>
+          <p:nvPr/>
+        </p:nvSpPr>
+        <p:spPr>
+          <a:xfrm>
+            <a:off x="1325880" y="4206240"/>
+            <a:ext cx="4389120" cy="384048"/>
+          </a:xfrm>
+          <a:prstGeom prst="rect">
+            <a:avLst/>
+          </a:prstGeom>
+          <a:noFill/>
+          <a:ln/>
+        </p:spPr>
+        <p:txBody>
+          <a:bodyPr wrap="square" lIns="0" tIns="0" rIns="0" bIns="0" rtlCol="0" anchor="ctr"/>
+          <a:lstStyle/>
+          <a:p>
+            <a:pPr indent="0" marL="0">
+              <a:buNone/>
+            </a:pPr>
+            <a:r>
+              <a:rPr lang="en-US" sz="1700" b="1" dirty="0">
+                <a:solidFill>
+                  <a:schemeClr val="tx2"/>
+                </a:solidFill>
+                <a:latin typeface="Times New Roman" pitchFamily="34" charset="0"/>
+                <a:ea typeface="Times New Roman" pitchFamily="34" charset="-122"/>
+                <a:cs typeface="Times New Roman" pitchFamily="34" charset="-120"/>
+              </a:rPr>
+              <a:t>Giới hạn topic config</a:t>
+            </a:r>
+            <a:endParaRPr lang="en-US" sz="1700" dirty="0"/>
+          </a:p>
+        </p:txBody>
+      </p:sp>
+      <p:sp>
+        <p:nvSpPr>
+          <p:cNvPr id="11" name="fixed desc 2"/>
+          <p:cNvSpPr txBox="1"/>
+          <p:nvPr/>
+        </p:nvSpPr>
+        <p:spPr>
+          <a:xfrm>
+            <a:off x="1325880" y="4617720"/>
+            <a:ext cx="4389120" cy="1280160"/>
+          </a:xfrm>
+          <a:prstGeom prst="rect">
+            <a:avLst/>
+          </a:prstGeom>
+          <a:noFill/>
+          <a:ln/>
+        </p:spPr>
+        <p:txBody>
+          <a:bodyPr wrap="square" lIns="0" tIns="0" rIns="0" bIns="0" rtlCol="0" anchor="t"/>
+          <a:lstStyle/>
+          <a:p>
+            <a:pPr indent="0" marL="0">
+              <a:buNone/>
+            </a:pPr>
+            <a:r>
+              <a:rPr lang="en-US" sz="1300" dirty="0">
+                <a:solidFill>
+                  <a:schemeClr val="tx1"/>
+                </a:solidFill>
+                <a:latin typeface="Arial" pitchFamily="34" charset="0"/>
+                <a:ea typeface="Arial" pitchFamily="34" charset="-122"/>
+                <a:cs typeface="Arial" pitchFamily="34" charset="-120"/>
+              </a:rPr>
+              <a:t>Firmware chỉ nhận ngưỡng là số trong phạm vi an toàn, giữ khoảng hysteresis; ngưỡng khoá nước không được hạ dưới 1200. Gói sai bị REJECTED và giữ ngưỡng cũ.</a:t>
+            </a:r>
+            <a:endParaRPr lang="en-US" sz="1300" dirty="0"/>
+          </a:p>
+        </p:txBody>
+      </p:sp>
+      <p:sp>
+        <p:nvSpPr>
+          <p:cNvPr id="12" name="todo panel"/>
           <p:cNvSpPr/>
           <p:nvPr/>
         </p:nvSpPr>
         <p:spPr>
           <a:xfrm>
-            <a:off x="548640" y="2743200"/>
-            <a:ext cx="457200" cy="457200"/>
-          </a:xfrm>
-          <a:prstGeom prst="ellipse">
-            <a:avLst/>
+            <a:off x="6245352" y="1691640"/>
+            <a:ext cx="5394960" cy="4480560"/>
+          </a:xfrm>
+          <a:prstGeom prst="roundRect">
+            <a:avLst>
+              <a:gd name="adj" fmla="val 1633"/>
+            </a:avLst>
           </a:prstGeom>
           <a:solidFill>
-            <a:schemeClr val="accent4"/>
+            <a:schemeClr val="tx2"/>
           </a:solidFill>
           <a:ln w="12700">
             <a:solidFill>
-              <a:schemeClr val="accent4"/>
+              <a:schemeClr val="tx2"/>
             </a:solidFill>
             <a:prstDash val="solid"/>
           </a:ln>
@@ -6309,14 +6417,14 @@
       </p:sp>
       <p:sp>
         <p:nvSpPr>
-          <p:cNvPr id="10" name="issue number 2"/>
-          <p:cNvSpPr txBox="1"/>
-          <p:nvPr/>
-        </p:nvSpPr>
-        <p:spPr>
-          <a:xfrm>
-            <a:off x="548640" y="2743200"/>
-            <a:ext cx="457200" cy="457200"/>
+          <p:cNvPr id="13" name="todo heading"/>
+          <p:cNvSpPr txBox="1"/>
+          <p:nvPr/>
+        </p:nvSpPr>
+        <p:spPr>
+          <a:xfrm>
+            <a:off x="6565392" y="1874520"/>
+            <a:ext cx="4846320" cy="329184"/>
           </a:xfrm>
           <a:prstGeom prst="rect">
             <a:avLst/>
@@ -6328,135 +6436,34 @@
           <a:bodyPr wrap="square" lIns="0" tIns="0" rIns="0" bIns="0" rtlCol="0" anchor="ctr"/>
           <a:lstStyle/>
           <a:p>
-            <a:pPr algn="ctr" indent="0" marL="0">
-              <a:buNone/>
-            </a:pPr>
-            <a:r>
-              <a:rPr lang="en-US" sz="1600" b="1" dirty="0">
-                <a:solidFill>
-                  <a:schemeClr val="bg1"/>
+            <a:pPr indent="0" marL="0">
+              <a:buNone/>
+            </a:pPr>
+            <a:r>
+              <a:rPr lang="en-US" sz="1500" b="1" spc="100" kern="0" dirty="0">
+                <a:solidFill>
+                  <a:schemeClr val="accent1"/>
                 </a:solidFill>
                 <a:latin typeface="Times New Roman" pitchFamily="34" charset="0"/>
                 <a:ea typeface="Times New Roman" pitchFamily="34" charset="-122"/>
                 <a:cs typeface="Times New Roman" pitchFamily="34" charset="-120"/>
               </a:rPr>
-              <a:t>2</a:t>
-            </a:r>
-            <a:endParaRPr lang="en-US" sz="1600" dirty="0"/>
-          </a:p>
-        </p:txBody>
-      </p:sp>
-      <p:sp>
-        <p:nvSpPr>
-          <p:cNvPr id="11" name="issue title 2"/>
-          <p:cNvSpPr txBox="1"/>
-          <p:nvPr/>
-        </p:nvSpPr>
-        <p:spPr>
-          <a:xfrm>
-            <a:off x="1188720" y="2587752"/>
-            <a:ext cx="3017520" cy="768096"/>
-          </a:xfrm>
-          <a:prstGeom prst="rect">
-            <a:avLst/>
-          </a:prstGeom>
-          <a:noFill/>
-          <a:ln/>
-        </p:spPr>
-        <p:txBody>
-          <a:bodyPr wrap="square" lIns="0" tIns="0" rIns="0" bIns="0" rtlCol="0" anchor="ctr"/>
-          <a:lstStyle/>
-          <a:p>
-            <a:pPr indent="0" marL="0">
-              <a:buNone/>
-            </a:pPr>
-            <a:r>
-              <a:rPr lang="en-US" sz="1700" b="1" dirty="0">
-                <a:solidFill>
-                  <a:schemeClr val="tx2"/>
-                </a:solidFill>
-                <a:latin typeface="Times New Roman" pitchFamily="34" charset="0"/>
-                <a:ea typeface="Times New Roman" pitchFamily="34" charset="-122"/>
-                <a:cs typeface="Times New Roman" pitchFamily="34" charset="-120"/>
-              </a:rPr>
-              <a:t>Khoá topic config</a:t>
-            </a:r>
-            <a:endParaRPr lang="en-US" sz="1700" dirty="0"/>
-          </a:p>
-        </p:txBody>
-      </p:sp>
-      <p:sp>
-        <p:nvSpPr>
-          <p:cNvPr id="12" name="issue desc 2"/>
-          <p:cNvSpPr txBox="1"/>
-          <p:nvPr/>
-        </p:nvSpPr>
-        <p:spPr>
-          <a:xfrm>
-            <a:off x="4297680" y="2587752"/>
-            <a:ext cx="7315200" cy="768096"/>
-          </a:xfrm>
-          <a:prstGeom prst="rect">
-            <a:avLst/>
-          </a:prstGeom>
-          <a:noFill/>
-          <a:ln/>
-        </p:spPr>
-        <p:txBody>
-          <a:bodyPr wrap="square" lIns="0" tIns="0" rIns="0" bIns="0" rtlCol="0" anchor="ctr"/>
-          <a:lstStyle/>
-          <a:p>
-            <a:pPr indent="0" marL="0">
-              <a:buNone/>
-            </a:pPr>
-            <a:r>
-              <a:rPr lang="en-US" sz="1300" dirty="0">
-                <a:solidFill>
-                  <a:schemeClr val="tx1"/>
-                </a:solidFill>
-                <a:latin typeface="Arial" pitchFamily="34" charset="0"/>
-                <a:ea typeface="Arial" pitchFamily="34" charset="-122"/>
-                <a:cs typeface="Arial" pitchFamily="34" charset="-120"/>
-              </a:rPr>
-              <a:t>Topic config cho phép đổi ngưỡng từ xa, kể cả ngưỡng nước, mà chưa kiểm tra phạm vi. Trên broker công khai, cần giới hạn hoặc tắt để không vô hiệu khoá nước.</a:t>
-            </a:r>
-            <a:endParaRPr lang="en-US" sz="1300" dirty="0"/>
-          </a:p>
-        </p:txBody>
-      </p:sp>
-      <p:sp>
-        <p:nvSpPr>
-          <p:cNvPr id="13" name="issue divider 2"/>
+              <a:t>VIỆC TIẾP THEO</a:t>
+            </a:r>
+            <a:endParaRPr lang="en-US" sz="1500" dirty="0"/>
+          </a:p>
+        </p:txBody>
+      </p:sp>
+      <p:sp>
+        <p:nvSpPr>
+          <p:cNvPr id="14" name="todo badge 1"/>
           <p:cNvSpPr/>
           <p:nvPr/>
         </p:nvSpPr>
         <p:spPr>
           <a:xfrm>
-            <a:off x="1188720" y="3410712"/>
-            <a:ext cx="10451592" cy="0"/>
-          </a:xfrm>
-          <a:prstGeom prst="line">
-            <a:avLst/>
-          </a:prstGeom>
-          <a:noFill/>
-          <a:ln w="9525">
-            <a:solidFill>
-              <a:schemeClr val="accent5"/>
-            </a:solidFill>
-            <a:prstDash val="solid"/>
-          </a:ln>
-        </p:spPr>
-      </p:sp>
-      <p:sp>
-        <p:nvSpPr>
-          <p:cNvPr id="14" name="issue badge 3"/>
-          <p:cNvSpPr/>
-          <p:nvPr/>
-        </p:nvSpPr>
-        <p:spPr>
-          <a:xfrm>
-            <a:off x="548640" y="3639312"/>
-            <a:ext cx="457200" cy="457200"/>
+            <a:off x="6565392" y="2395728"/>
+            <a:ext cx="384048" cy="384048"/>
           </a:xfrm>
           <a:prstGeom prst="ellipse">
             <a:avLst/>
@@ -6474,14 +6481,14 @@
       </p:sp>
       <p:sp>
         <p:nvSpPr>
-          <p:cNvPr id="15" name="issue number 3"/>
-          <p:cNvSpPr txBox="1"/>
-          <p:nvPr/>
-        </p:nvSpPr>
-        <p:spPr>
-          <a:xfrm>
-            <a:off x="548640" y="3639312"/>
-            <a:ext cx="457200" cy="457200"/>
+          <p:cNvPr id="15" name="todo number 1"/>
+          <p:cNvSpPr txBox="1"/>
+          <p:nvPr/>
+        </p:nvSpPr>
+        <p:spPr>
+          <a:xfrm>
+            <a:off x="6565392" y="2395728"/>
+            <a:ext cx="384048" cy="384048"/>
           </a:xfrm>
           <a:prstGeom prst="rect">
             <a:avLst/>
@@ -6497,7 +6504,7 @@
               <a:buNone/>
             </a:pPr>
             <a:r>
-              <a:rPr lang="en-US" sz="1600" b="1" dirty="0">
+              <a:rPr lang="en-US" sz="1500" b="1" dirty="0">
                 <a:solidFill>
                   <a:schemeClr val="tx1"/>
                 </a:solidFill>
@@ -6505,22 +6512,22 @@
                 <a:ea typeface="Times New Roman" pitchFamily="34" charset="-122"/>
                 <a:cs typeface="Times New Roman" pitchFamily="34" charset="-120"/>
               </a:rPr>
-              <a:t>3</a:t>
-            </a:r>
-            <a:endParaRPr lang="en-US" sz="1600" dirty="0"/>
-          </a:p>
-        </p:txBody>
-      </p:sp>
-      <p:sp>
-        <p:nvSpPr>
-          <p:cNvPr id="16" name="issue title 3"/>
-          <p:cNvSpPr txBox="1"/>
-          <p:nvPr/>
-        </p:nvSpPr>
-        <p:spPr>
-          <a:xfrm>
-            <a:off x="1188720" y="3483864"/>
-            <a:ext cx="3017520" cy="768096"/>
+              <a:t>1</a:t>
+            </a:r>
+            <a:endParaRPr lang="en-US" sz="1500" dirty="0"/>
+          </a:p>
+        </p:txBody>
+      </p:sp>
+      <p:sp>
+        <p:nvSpPr>
+          <p:cNvPr id="16" name="todo title 1"/>
+          <p:cNvSpPr txBox="1"/>
+          <p:nvPr/>
+        </p:nvSpPr>
+        <p:spPr>
+          <a:xfrm>
+            <a:off x="7132320" y="2377440"/>
+            <a:ext cx="4297680" cy="384048"/>
           </a:xfrm>
           <a:prstGeom prst="rect">
             <a:avLst/>
@@ -6538,7 +6545,7 @@
             <a:r>
               <a:rPr lang="en-US" sz="1700" b="1" dirty="0">
                 <a:solidFill>
-                  <a:schemeClr val="tx2"/>
+                  <a:schemeClr val="bg1"/>
                 </a:solidFill>
                 <a:latin typeface="Times New Roman" pitchFamily="34" charset="0"/>
                 <a:ea typeface="Times New Roman" pitchFamily="34" charset="-122"/>
@@ -6552,23 +6559,23 @@
       </p:sp>
       <p:sp>
         <p:nvSpPr>
-          <p:cNvPr id="17" name="issue desc 3"/>
-          <p:cNvSpPr txBox="1"/>
-          <p:nvPr/>
-        </p:nvSpPr>
-        <p:spPr>
-          <a:xfrm>
-            <a:off x="4297680" y="3483864"/>
-            <a:ext cx="7315200" cy="768096"/>
-          </a:xfrm>
-          <a:prstGeom prst="rect">
-            <a:avLst/>
-          </a:prstGeom>
-          <a:noFill/>
-          <a:ln/>
-        </p:spPr>
-        <p:txBody>
-          <a:bodyPr wrap="square" lIns="0" tIns="0" rIns="0" bIns="0" rtlCol="0" anchor="ctr"/>
+          <p:cNvPr id="17" name="todo desc 1"/>
+          <p:cNvSpPr txBox="1"/>
+          <p:nvPr/>
+        </p:nvSpPr>
+        <p:spPr>
+          <a:xfrm>
+            <a:off x="7132320" y="2788920"/>
+            <a:ext cx="4297680" cy="685800"/>
+          </a:xfrm>
+          <a:prstGeom prst="rect">
+            <a:avLst/>
+          </a:prstGeom>
+          <a:noFill/>
+          <a:ln/>
+        </p:spPr>
+        <p:txBody>
+          <a:bodyPr wrap="square" lIns="0" tIns="0" rIns="0" bIns="0" rtlCol="0" anchor="t"/>
           <a:lstStyle/>
           <a:p>
             <a:pPr indent="0" marL="0">
@@ -6577,7 +6584,7 @@
             <a:r>
               <a:rPr lang="en-US" sz="1300" dirty="0">
                 <a:solidFill>
-                  <a:schemeClr val="tx1"/>
+                  <a:schemeClr val="accent3"/>
                 </a:solidFill>
                 <a:latin typeface="Arial" pitchFamily="34" charset="0"/>
                 <a:ea typeface="Arial" pitchFamily="34" charset="-122"/>
@@ -6591,37 +6598,14 @@
       </p:sp>
       <p:sp>
         <p:nvSpPr>
-          <p:cNvPr id="18" name="issue divider 3"/>
+          <p:cNvPr id="18" name="todo badge 2"/>
           <p:cNvSpPr/>
           <p:nvPr/>
         </p:nvSpPr>
         <p:spPr>
           <a:xfrm>
-            <a:off x="1188720" y="4306824"/>
-            <a:ext cx="10451592" cy="0"/>
-          </a:xfrm>
-          <a:prstGeom prst="line">
-            <a:avLst/>
-          </a:prstGeom>
-          <a:noFill/>
-          <a:ln w="9525">
-            <a:solidFill>
-              <a:schemeClr val="accent5"/>
-            </a:solidFill>
-            <a:prstDash val="solid"/>
-          </a:ln>
-        </p:spPr>
-      </p:sp>
-      <p:sp>
-        <p:nvSpPr>
-          <p:cNvPr id="19" name="issue badge 4"/>
-          <p:cNvSpPr/>
-          <p:nvPr/>
-        </p:nvSpPr>
-        <p:spPr>
-          <a:xfrm>
-            <a:off x="548640" y="4535424"/>
-            <a:ext cx="457200" cy="457200"/>
+            <a:off x="6565392" y="3630168"/>
+            <a:ext cx="384048" cy="384048"/>
           </a:xfrm>
           <a:prstGeom prst="ellipse">
             <a:avLst/>
@@ -6639,14 +6623,14 @@
       </p:sp>
       <p:sp>
         <p:nvSpPr>
-          <p:cNvPr id="20" name="issue number 4"/>
-          <p:cNvSpPr txBox="1"/>
-          <p:nvPr/>
-        </p:nvSpPr>
-        <p:spPr>
-          <a:xfrm>
-            <a:off x="548640" y="4535424"/>
-            <a:ext cx="457200" cy="457200"/>
+          <p:cNvPr id="19" name="todo number 2"/>
+          <p:cNvSpPr txBox="1"/>
+          <p:nvPr/>
+        </p:nvSpPr>
+        <p:spPr>
+          <a:xfrm>
+            <a:off x="6565392" y="3630168"/>
+            <a:ext cx="384048" cy="384048"/>
           </a:xfrm>
           <a:prstGeom prst="rect">
             <a:avLst/>
@@ -6662,7 +6646,7 @@
               <a:buNone/>
             </a:pPr>
             <a:r>
-              <a:rPr lang="en-US" sz="1600" b="1" dirty="0">
+              <a:rPr lang="en-US" sz="1500" b="1" dirty="0">
                 <a:solidFill>
                   <a:schemeClr val="tx1"/>
                 </a:solidFill>
@@ -6670,22 +6654,22 @@
                 <a:ea typeface="Times New Roman" pitchFamily="34" charset="-122"/>
                 <a:cs typeface="Times New Roman" pitchFamily="34" charset="-120"/>
               </a:rPr>
-              <a:t>4</a:t>
-            </a:r>
-            <a:endParaRPr lang="en-US" sz="1600" dirty="0"/>
-          </a:p>
-        </p:txBody>
-      </p:sp>
-      <p:sp>
-        <p:nvSpPr>
-          <p:cNvPr id="21" name="issue title 4"/>
-          <p:cNvSpPr txBox="1"/>
-          <p:nvPr/>
-        </p:nvSpPr>
-        <p:spPr>
-          <a:xfrm>
-            <a:off x="1188720" y="4379976"/>
-            <a:ext cx="3017520" cy="768096"/>
+              <a:t>2</a:t>
+            </a:r>
+            <a:endParaRPr lang="en-US" sz="1500" dirty="0"/>
+          </a:p>
+        </p:txBody>
+      </p:sp>
+      <p:sp>
+        <p:nvSpPr>
+          <p:cNvPr id="20" name="todo title 2"/>
+          <p:cNvSpPr txBox="1"/>
+          <p:nvPr/>
+        </p:nvSpPr>
+        <p:spPr>
+          <a:xfrm>
+            <a:off x="7132320" y="3611880"/>
+            <a:ext cx="4297680" cy="384048"/>
           </a:xfrm>
           <a:prstGeom prst="rect">
             <a:avLst/>
@@ -6703,7 +6687,7 @@
             <a:r>
               <a:rPr lang="en-US" sz="1700" b="1" dirty="0">
                 <a:solidFill>
-                  <a:schemeClr val="tx2"/>
+                  <a:schemeClr val="bg1"/>
                 </a:solidFill>
                 <a:latin typeface="Times New Roman" pitchFamily="34" charset="0"/>
                 <a:ea typeface="Times New Roman" pitchFamily="34" charset="-122"/>
@@ -6717,23 +6701,23 @@
       </p:sp>
       <p:sp>
         <p:nvSpPr>
-          <p:cNvPr id="22" name="issue desc 4"/>
-          <p:cNvSpPr txBox="1"/>
-          <p:nvPr/>
-        </p:nvSpPr>
-        <p:spPr>
-          <a:xfrm>
-            <a:off x="4297680" y="4379976"/>
-            <a:ext cx="7315200" cy="768096"/>
-          </a:xfrm>
-          <a:prstGeom prst="rect">
-            <a:avLst/>
-          </a:prstGeom>
-          <a:noFill/>
-          <a:ln/>
-        </p:spPr>
-        <p:txBody>
-          <a:bodyPr wrap="square" lIns="0" tIns="0" rIns="0" bIns="0" rtlCol="0" anchor="ctr"/>
+          <p:cNvPr id="21" name="todo desc 2"/>
+          <p:cNvSpPr txBox="1"/>
+          <p:nvPr/>
+        </p:nvSpPr>
+        <p:spPr>
+          <a:xfrm>
+            <a:off x="7132320" y="4023360"/>
+            <a:ext cx="4297680" cy="685800"/>
+          </a:xfrm>
+          <a:prstGeom prst="rect">
+            <a:avLst/>
+          </a:prstGeom>
+          <a:noFill/>
+          <a:ln/>
+        </p:spPr>
+        <p:txBody>
+          <a:bodyPr wrap="square" lIns="0" tIns="0" rIns="0" bIns="0" rtlCol="0" anchor="t"/>
           <a:lstStyle/>
           <a:p>
             <a:pPr indent="0" marL="0">
@@ -6742,7 +6726,7 @@
             <a:r>
               <a:rPr lang="en-US" sz="1300" dirty="0">
                 <a:solidFill>
-                  <a:schemeClr val="tx1"/>
+                  <a:schemeClr val="accent3"/>
                 </a:solidFill>
                 <a:latin typeface="Arial" pitchFamily="34" charset="0"/>
                 <a:ea typeface="Arial" pitchFamily="34" charset="-122"/>
@@ -6756,22 +6740,24 @@
       </p:sp>
       <p:sp>
         <p:nvSpPr>
-          <p:cNvPr id="23" name="issue divider 4"/>
+          <p:cNvPr id="22" name="todo badge 3"/>
           <p:cNvSpPr/>
           <p:nvPr/>
         </p:nvSpPr>
         <p:spPr>
           <a:xfrm>
-            <a:off x="1188720" y="5202936"/>
-            <a:ext cx="10451592" cy="0"/>
-          </a:xfrm>
-          <a:prstGeom prst="line">
-            <a:avLst/>
-          </a:prstGeom>
-          <a:noFill/>
-          <a:ln w="9525">
+            <a:off x="6565392" y="4864608"/>
+            <a:ext cx="384048" cy="384048"/>
+          </a:xfrm>
+          <a:prstGeom prst="ellipse">
+            <a:avLst/>
+          </a:prstGeom>
+          <a:solidFill>
+            <a:schemeClr val="accent1"/>
+          </a:solidFill>
+          <a:ln w="12700">
             <a:solidFill>
-              <a:schemeClr val="accent5"/>
+              <a:schemeClr val="accent1"/>
             </a:solidFill>
             <a:prstDash val="solid"/>
           </a:ln>
@@ -6779,39 +6765,14 @@
       </p:sp>
       <p:sp>
         <p:nvSpPr>
-          <p:cNvPr id="24" name="issue badge 5"/>
-          <p:cNvSpPr/>
-          <p:nvPr/>
-        </p:nvSpPr>
-        <p:spPr>
-          <a:xfrm>
-            <a:off x="548640" y="5431536"/>
-            <a:ext cx="457200" cy="457200"/>
-          </a:xfrm>
-          <a:prstGeom prst="ellipse">
-            <a:avLst/>
-          </a:prstGeom>
-          <a:solidFill>
-            <a:schemeClr val="accent2"/>
-          </a:solidFill>
-          <a:ln w="12700">
-            <a:solidFill>
-              <a:schemeClr val="accent2"/>
-            </a:solidFill>
-            <a:prstDash val="solid"/>
-          </a:ln>
-        </p:spPr>
-      </p:sp>
-      <p:sp>
-        <p:nvSpPr>
-          <p:cNvPr id="25" name="issue number 5"/>
-          <p:cNvSpPr txBox="1"/>
-          <p:nvPr/>
-        </p:nvSpPr>
-        <p:spPr>
-          <a:xfrm>
-            <a:off x="548640" y="5431536"/>
-            <a:ext cx="457200" cy="457200"/>
+          <p:cNvPr id="23" name="todo number 3"/>
+          <p:cNvSpPr txBox="1"/>
+          <p:nvPr/>
+        </p:nvSpPr>
+        <p:spPr>
+          <a:xfrm>
+            <a:off x="6565392" y="4864608"/>
+            <a:ext cx="384048" cy="384048"/>
           </a:xfrm>
           <a:prstGeom prst="rect">
             <a:avLst/>
@@ -6827,30 +6788,30 @@
               <a:buNone/>
             </a:pPr>
             <a:r>
-              <a:rPr lang="en-US" sz="1600" b="1" dirty="0">
-                <a:solidFill>
-                  <a:schemeClr val="bg1"/>
+              <a:rPr lang="en-US" sz="1500" b="1" dirty="0">
+                <a:solidFill>
+                  <a:schemeClr val="tx1"/>
                 </a:solidFill>
                 <a:latin typeface="Times New Roman" pitchFamily="34" charset="0"/>
                 <a:ea typeface="Times New Roman" pitchFamily="34" charset="-122"/>
                 <a:cs typeface="Times New Roman" pitchFamily="34" charset="-120"/>
               </a:rPr>
-              <a:t>5</a:t>
-            </a:r>
-            <a:endParaRPr lang="en-US" sz="1600" dirty="0"/>
-          </a:p>
-        </p:txBody>
-      </p:sp>
-      <p:sp>
-        <p:nvSpPr>
-          <p:cNvPr id="26" name="issue title 5"/>
-          <p:cNvSpPr txBox="1"/>
-          <p:nvPr/>
-        </p:nvSpPr>
-        <p:spPr>
-          <a:xfrm>
-            <a:off x="1188720" y="5276088"/>
-            <a:ext cx="3017520" cy="768096"/>
+              <a:t>3</a:t>
+            </a:r>
+            <a:endParaRPr lang="en-US" sz="1500" dirty="0"/>
+          </a:p>
+        </p:txBody>
+      </p:sp>
+      <p:sp>
+        <p:nvSpPr>
+          <p:cNvPr id="24" name="todo title 3"/>
+          <p:cNvSpPr txBox="1"/>
+          <p:nvPr/>
+        </p:nvSpPr>
+        <p:spPr>
+          <a:xfrm>
+            <a:off x="7132320" y="4846320"/>
+            <a:ext cx="4297680" cy="384048"/>
           </a:xfrm>
           <a:prstGeom prst="rect">
             <a:avLst/>
@@ -6868,7 +6829,7 @@
             <a:r>
               <a:rPr lang="en-US" sz="1700" b="1" dirty="0">
                 <a:solidFill>
-                  <a:schemeClr val="tx2"/>
+                  <a:schemeClr val="bg1"/>
                 </a:solidFill>
                 <a:latin typeface="Times New Roman" pitchFamily="34" charset="0"/>
                 <a:ea typeface="Times New Roman" pitchFamily="34" charset="-122"/>
@@ -6882,23 +6843,23 @@
       </p:sp>
       <p:sp>
         <p:nvSpPr>
-          <p:cNvPr id="27" name="issue desc 5"/>
-          <p:cNvSpPr txBox="1"/>
-          <p:nvPr/>
-        </p:nvSpPr>
-        <p:spPr>
-          <a:xfrm>
-            <a:off x="4297680" y="5276088"/>
-            <a:ext cx="7315200" cy="768096"/>
-          </a:xfrm>
-          <a:prstGeom prst="rect">
-            <a:avLst/>
-          </a:prstGeom>
-          <a:noFill/>
-          <a:ln/>
-        </p:spPr>
-        <p:txBody>
-          <a:bodyPr wrap="square" lIns="0" tIns="0" rIns="0" bIns="0" rtlCol="0" anchor="ctr"/>
+          <p:cNvPr id="25" name="todo desc 3"/>
+          <p:cNvSpPr txBox="1"/>
+          <p:nvPr/>
+        </p:nvSpPr>
+        <p:spPr>
+          <a:xfrm>
+            <a:off x="7132320" y="5257800"/>
+            <a:ext cx="4297680" cy="685800"/>
+          </a:xfrm>
+          <a:prstGeom prst="rect">
+            <a:avLst/>
+          </a:prstGeom>
+          <a:noFill/>
+          <a:ln/>
+        </p:spPr>
+        <p:txBody>
+          <a:bodyPr wrap="square" lIns="0" tIns="0" rIns="0" bIns="0" rtlCol="0" anchor="t"/>
           <a:lstStyle/>
           <a:p>
             <a:pPr indent="0" marL="0">
@@ -6907,13 +6868,13 @@
             <a:r>
               <a:rPr lang="en-US" sz="1300" dirty="0">
                 <a:solidFill>
-                  <a:schemeClr val="tx1"/>
+                  <a:schemeClr val="accent3"/>
                 </a:solidFill>
                 <a:latin typeface="Arial" pitchFamily="34" charset="0"/>
                 <a:ea typeface="Arial" pitchFamily="34" charset="-122"/>
                 <a:cs typeface="Arial" pitchFamily="34" charset="-120"/>
               </a:rPr>
-              <a:t>Cập nhật các khoá an toàn tuần 7 vào s3_physical.cpp và chạy trên ESP32.</a:t>
+              <a:t>Đưa các khoá an toàn tuần 7 vào s3_physical.cpp và chạy trên ESP32.</a:t>
             </a:r>
             <a:endParaRPr lang="en-US" sz="1300" dirty="0"/>
           </a:p>
@@ -11946,7 +11907,7 @@
         <p:spPr>
           <a:xfrm>
             <a:off x="5806440" y="1691640"/>
-            <a:ext cx="5833872" cy="2786327"/>
+            <a:ext cx="5833872" cy="2438036"/>
           </a:xfrm>
           <a:prstGeom prst="rect">
             <a:avLst/>
@@ -11962,7 +11923,7 @@
         <p:spPr>
           <a:xfrm>
             <a:off x="5806440" y="1691640"/>
-            <a:ext cx="5833872" cy="2786327"/>
+            <a:ext cx="5833872" cy="2438036"/>
           </a:xfrm>
           <a:prstGeom prst="rect">
             <a:avLst/>
@@ -11988,7 +11949,7 @@
         </p:nvSpPr>
         <p:spPr>
           <a:xfrm>
-            <a:off x="5806440" y="4587695"/>
+            <a:off x="5806440" y="4239404"/>
             <a:ext cx="5833872" cy="457200"/>
           </a:xfrm>
           <a:prstGeom prst="rect">
@@ -14102,7 +14063,7 @@
                 <a:ea typeface="Arial" pitchFamily="34" charset="-122"/>
                 <a:cs typeface="Arial" pitchFamily="34" charset="-120"/>
               </a:rPr>
-              <a:t>Bàn giao: tab Node-RED của Người 3, báo cáo tuan6-e2e-integration.md và kịch bản video demo-guide-video.md.</a:t>
+              <a:t>Bàn giao: tab Node-RED của Người 3 (nút test lệnh đi qua gateway), báo cáo tuan6-e2e-integration.md và kịch bản video demo-guide-video.md.</a:t>
             </a:r>
             <a:endParaRPr lang="en-US" sz="1200" dirty="0"/>
           </a:p>
@@ -14347,7 +14308,7 @@
                 <a:ea typeface="Times New Roman" pitchFamily="34" charset="-122"/>
                 <a:cs typeface="Times New Roman" pitchFamily="34" charset="-120"/>
               </a:rPr>
-              <a:t>2 rule tự gửi lệnh khi dashboard ở AUTO · không tính bấm nút thủ công là automation</a:t>
+              <a:t>Một bộ rule duy nhất, đi qua gateway, chỉ chạy khi dashboard ở AUTO · giá trị theo thống nhất của nhóm</a:t>
             </a:r>
             <a:endParaRPr lang="en-US" sz="1600" dirty="0"/>
           </a:p>
@@ -14505,7 +14466,7 @@
                 <a:ea typeface="Arial" pitchFamily="34" charset="-122"/>
                 <a:cs typeface="Arial" pitchFamily="34" charset="-120"/>
               </a:rPr>
-              <a:t>Khung 06:00–20:00 (giờ tắt 20:00): bật khi tối, tắt khi đủ sáng</a:t>
+              <a:t>Khung 06:00–21:00 (giờ tắt 21:00): bật khi tối, tắt khi đủ sáng</a:t>
             </a:r>
             <a:endParaRPr lang="en-US" sz="1300" dirty="0"/>
           </a:p>
@@ -14726,7 +14687,7 @@
                 <a:ea typeface="Arial" pitchFamily="34" charset="-122"/>
                 <a:cs typeface="Arial" pitchFamily="34" charset="-120"/>
               </a:rPr>
-              <a:t>Relay phun chuyển ON → OFF thì bật quạt 180 s</a:t>
+              <a:t>Relay phun chuyển ON → OFF thì bật quạt 60 s</a:t>
             </a:r>
             <a:endParaRPr lang="en-US" sz="1300" dirty="0"/>
           </a:p>

</xml_diff>